<commit_message>
fix(deck): legibility pass — table fits, clean architecture, no overlaps
- Benefits table: shortened cells so all 5 rows fit; the "UiPath products used"
  cell no longer overflows and pushes the last row off the slide.
- Architecture: replaced the clobber-prone shared asset with a self-drawn clean
  white flow (cg-arch.png, matplotlib) — legible labels, placed below the caption
  with no tag overlap.
- Live-proof chart: stable cg-chart.png, nudged down so it clears the score tag.
All info legible; deck/CG-submission.pptx (+ .pdf) is the file to submit.

Co-Authored-By: Claude Opus 4.8 (1M context) <noreply@anthropic.com>
</commit_message>
<xml_diff>
--- a/deck/CG-submission.pptx
+++ b/deck/CG-submission.pptx
@@ -26387,7 +26387,7 @@
                           <a:cs typeface="Arial"/>
                           <a:sym typeface="Arial"/>
                         </a:rPr>
-                        <a:t>Platform, QA and FinOps engineers shipping AI agents to production</a:t>
+                        <a:t>Platform, QA and FinOps engineers shipping AI agents</a:t>
                       </a:r>
                       <a:endParaRPr b="1" i="0" sz="1800" u="none" cap="none" strike="noStrike">
                         <a:solidFill>
@@ -26747,7 +26747,7 @@
                           <a:cs typeface="Arial"/>
                           <a:sym typeface="Arial"/>
                         </a:rPr>
-                        <a:t>Any enterprise running production AI agents: finance, insurance, BPO, shared services</a:t>
+                        <a:t>Enterprises running production AI agents (finance, insurance, BPO)</a:t>
                       </a:r>
                       <a:endParaRPr b="0" i="0" sz="1800" u="none" cap="none" strike="noStrike">
                         <a:solidFill>
@@ -26927,7 +26927,7 @@
                           <a:cs typeface="Arial"/>
                           <a:sym typeface="Arial"/>
                         </a:rPr>
-                        <a:t>Test Cloud (the gate), Coded Agents / Python SDK (engine + Cost Explainer), Orchestrator (serverless job), Action Center (HITL), Document Understanding (patient), AI Trust Layer LLM Gateway, API Workflows (pricing)</a:t>
+                        <a:t>Test Cloud, Coded Agents (Python SDK), Orchestrator, Action Center, Document Understanding, AI Trust Layer Gateway</a:t>
                       </a:r>
                       <a:endParaRPr b="0" i="0" sz="1800" u="none" cap="none" strike="noStrike">
                         <a:solidFill>
@@ -27107,7 +27107,7 @@
                           <a:cs typeface="Arial"/>
                           <a:sym typeface="Arial"/>
                         </a:rPr>
-                        <a:t>LangChain / CrewAI as external agent-under-test, OpenTelemetry, built with Claude Code via uip skills, bootstrap statistical cost bands</a:t>
+                        <a:t>LangChain / CrewAI agent-under-test, OpenTelemetry, Claude Code via uip skills</a:t>
                       </a:r>
                       <a:endParaRPr b="0" i="0" sz="1800" u="none" cap="none" strike="noStrike">
                         <a:solidFill>
@@ -27868,7 +27868,7 @@
       </p:sp>
       <p:pic>
         <p:nvPicPr>
-          <p:cNvPr id="206" name="Picture 205" descr="architecture.png"/>
+          <p:cNvPr id="206" name="Picture 205" descr="cg-arch.png"/>
           <p:cNvPicPr>
             <a:picLocks noChangeAspect="1"/>
           </p:cNvPicPr>
@@ -27882,8 +27882,8 @@
         </p:blipFill>
         <p:spPr>
           <a:xfrm>
-            <a:off x="2468880" y="2240280"/>
-            <a:ext cx="7223760" cy="1978213"/>
+            <a:off x="640080" y="3063240"/>
+            <a:ext cx="10881360" cy="2750088"/>
           </a:xfrm>
           <a:prstGeom prst="rect">
             <a:avLst/>
@@ -28254,7 +28254,7 @@
       </p:sp>
       <p:pic>
         <p:nvPicPr>
-          <p:cNvPr id="214" name="Picture 213" descr="cost-regression.png"/>
+          <p:cNvPr id="214" name="Picture 213" descr="cg-chart.png"/>
           <p:cNvPicPr>
             <a:picLocks noChangeAspect="1"/>
           </p:cNvPicPr>
@@ -28268,8 +28268,8 @@
         </p:blipFill>
         <p:spPr>
           <a:xfrm>
-            <a:off x="2743200" y="2788920"/>
-            <a:ext cx="6675120" cy="3754755"/>
+            <a:off x="3127248" y="3017520"/>
+            <a:ext cx="5943600" cy="3343275"/>
           </a:xfrm>
           <a:prstGeom prst="rect">
             <a:avLst/>

</xml_diff>